<commit_message>
Añade el QR del repositorio y completa las URLs del taller
- docs/qr-repo.png: QR con corrección de errores alta (H) que apunta al repo
- Slides 1 y 18: el marcador punteado se sustituye por el QR real, embebido
  como data URI en index.html y como imagen en el .pptx
- Se completan <URL-CORTA> y <CONTACTO-PONENTE> en todo el material
- Slide 4: el comando de clonado se parte en dos líneas para que quepa

Co-Authored-By: Claude Opus 5 <noreply@anthropic.com>
</commit_message>
<xml_diff>
--- a/slides/workshop-textract.pptx
+++ b/slides/workshop-textract.pptx
@@ -741,7 +741,7 @@
           <a:lstStyle/>
           <a:p>
             <a:r>
-              <a:t>3 min (min 0-3). Proyectada desde antes de las 15:00. Decir textualmente las tres reglas; no explicar nada mas: el objetivo es que escaneen el QR y que CloudShell empiece a arrancar. Pedir dos conteos de manos (laptop / cuenta AWS) y anotar el numero: decide el plan de recorte. Presentar a los helpers por nombre. PENDIENTE: reemplazar el cuadro QR por la imagen real y &lt;URL-CORTA&gt;.</a:t>
+              <a:t>3 min (min 0-3). Proyectada desde antes de las 15:00. Decir textualmente las tres reglas; no explicar nada mas: el objetivo es que escaneen el QR y que CloudShell empiece a arrancar. Pedir dos conteos de manos (laptop / cuenta AWS) y anotar el numero: decide el plan de recorte. Presentar a los helpers por nombre. El QR de la slide apunta al repositorio publicado.</a:t>
             </a:r>
           </a:p>
         </p:txBody>
@@ -1263,7 +1263,7 @@
           <a:lstStyle/>
           <a:p>
             <a:r>
-              <a:t>3 min (min 67-70): 2 o 3 preguntas cortas. Invitar a continuar en el pasillo y en el canal del AWS User Group Ecuador. Recoger la factura impresa y los cheat sheets sobrantes. Cerrar CloudShell. PENDIENTE: reemplazar el cuadro QR por la imagen real, &lt;URL-CORTA&gt; y &lt;CONTACTO-PONENTE&gt;.</a:t>
+              <a:t>3 min (min 67-70): 2 o 3 preguntas cortas. Invitar a continuar en el pasillo y en el canal del AWS User Group Ecuador. Recoger la factura impresa y los cheat sheets sobrantes. Cerrar CloudShell.</a:t>
             </a:r>
           </a:p>
         </p:txBody>
@@ -1437,7 +1437,7 @@
           <a:lstStyle/>
           <a:p>
             <a:r>
-              <a:t>8 min (min 10-18). El bloque mas importante: caminar por la sala con los helpers. 00_check.py imprime el account id porque sts:GetCallerIdentity no requiere permisos, y la region porque Textract no existe en sa-east-1. Cualquier otro error sale en rojo con la linea --offline. Min 16: semaforo de manos; con mas del 30 % en rojo, Lab 3 pasa a demo y el bonus se elimina. PENDIENTE: reemplazar &lt;URL-REPO&gt;.</a:t>
+              <a:t>8 min (min 10-18). El bloque mas importante: caminar por la sala con los helpers. 00_check.py imprime el account id porque sts:GetCallerIdentity no requiere permisos, y la region porque Textract no existe en sa-east-1. Cualquier otro error sale en rojo con la linea --offline. Min 16: semaforo de manos; con mas del 30 % en rojo, Lab 3 pasa a demo y el bonus se elimina. PENDIENTE: reemplazar https://github.com/jossuema/textract-ec.git.</a:t>
             </a:r>
           </a:p>
         </p:txBody>
@@ -6728,68 +6728,30 @@
           </a:p>
         </p:txBody>
       </p:sp>
-      <p:sp>
-        <p:nvSpPr>
-          <p:cNvPr id="10" name="TextBox 9"/>
-          <p:cNvSpPr txBox="1"/>
-          <p:nvPr/>
-        </p:nvSpPr>
-        <p:spPr>
-          <a:xfrm>
-            <a:off x="5852160" y="1673352"/>
-            <a:ext cx="1280160" cy="457200"/>
-          </a:xfrm>
-          <a:prstGeom prst="rect">
-            <a:avLst/>
-          </a:prstGeom>
-          <a:noFill/>
-        </p:spPr>
-        <p:txBody>
-          <a:bodyPr wrap="square" lIns="0" rIns="0" tIns="0" bIns="0" anchor="ctr">
-            <a:spAutoFit/>
-          </a:bodyPr>
-          <a:lstStyle/>
-          <a:p>
-            <a:pPr algn="ctr">
-              <a:spcBef>
-                <a:spcPts val="0"/>
-              </a:spcBef>
-              <a:spcAft>
-                <a:spcPts val="0"/>
-              </a:spcAft>
-            </a:pPr>
-            <a:r>
-              <a:rPr sz="1300" b="1" i="0">
-                <a:solidFill>
-                  <a:srgbClr val="0B1338"/>
-                </a:solidFill>
-                <a:latin typeface="Arial"/>
-              </a:rPr>
-              <a:t>QR</a:t>
-            </a:r>
-          </a:p>
-          <a:p>
-            <a:pPr algn="ctr">
-              <a:spcBef>
-                <a:spcPts val="0"/>
-              </a:spcBef>
-              <a:spcAft>
-                <a:spcPts val="0"/>
-              </a:spcAft>
-            </a:pPr>
-            <a:r>
-              <a:rPr sz="700" b="0" i="0">
-                <a:solidFill>
-                  <a:srgbClr val="5A6076"/>
-                </a:solidFill>
-                <a:latin typeface="Arial"/>
-              </a:rPr>
-              <a:t>github.com/&lt;usuario&gt;/
-textract-ec</a:t>
-            </a:r>
-          </a:p>
-        </p:txBody>
-      </p:sp>
+      <p:pic>
+        <p:nvPicPr>
+          <p:cNvPr id="10" name="Picture 9" descr="qr-repo.png"/>
+          <p:cNvPicPr>
+            <a:picLocks noChangeAspect="1"/>
+          </p:cNvPicPr>
+          <p:nvPr/>
+        </p:nvPicPr>
+        <p:blipFill>
+          <a:blip r:embed="rId5"/>
+          <a:stretch>
+            <a:fillRect/>
+          </a:stretch>
+        </p:blipFill>
+        <p:spPr>
+          <a:xfrm>
+            <a:off x="5879592" y="1261872"/>
+            <a:ext cx="1225296" cy="1225296"/>
+          </a:xfrm>
+          <a:prstGeom prst="rect">
+            <a:avLst/>
+          </a:prstGeom>
+        </p:spPr>
+      </p:pic>
       <p:sp>
         <p:nvSpPr>
           <p:cNvPr id="11" name="TextBox 10"/>
@@ -6798,8 +6760,8 @@
         </p:nvSpPr>
         <p:spPr>
           <a:xfrm>
-            <a:off x="7498079" y="1188720"/>
-            <a:ext cx="1143000" cy="1417320"/>
+            <a:off x="7315200" y="1389888"/>
+            <a:ext cx="1325880" cy="1005840"/>
           </a:xfrm>
           <a:prstGeom prst="rect">
             <a:avLst/>
@@ -6821,48 +6783,109 @@
               </a:spcAft>
             </a:pPr>
             <a:r>
-              <a:rPr sz="900" b="1" i="0">
+              <a:rPr sz="950" b="1" i="0">
                 <a:solidFill>
                   <a:srgbClr val="C98FD8"/>
                 </a:solidFill>
                 <a:latin typeface="Arial"/>
               </a:rPr>
-              <a:t>ABRE ESTO AHORA</a:t>
+              <a:t>ABRE ESTO</a:t>
+            </a:r>
+          </a:p>
+          <a:p>
+            <a:pPr algn="l">
+              <a:spcBef>
+                <a:spcPts val="0"/>
+              </a:spcBef>
+              <a:spcAft>
+                <a:spcPts val="0"/>
+              </a:spcAft>
+            </a:pPr>
+            <a:r>
+              <a:rPr sz="950" b="1" i="0">
+                <a:solidFill>
+                  <a:srgbClr val="C98FD8"/>
+                </a:solidFill>
+                <a:latin typeface="Arial"/>
+              </a:rPr>
+              <a:t>AHORA</a:t>
             </a:r>
           </a:p>
           <a:p>
             <a:pPr algn="l">
               <a:lnSpc>
-                <a:spcPct val="100000"/>
+                <a:spcPct val="110000"/>
               </a:lnSpc>
               <a:spcBef>
-                <a:spcPts val="600"/>
-              </a:spcBef>
-              <a:spcAft>
-                <a:spcPts val="0"/>
-              </a:spcAft>
-            </a:pPr>
-            <a:r>
-              <a:rPr sz="1200" b="1" i="0">
+                <a:spcPts val="500"/>
+              </a:spcBef>
+              <a:spcAft>
+                <a:spcPts val="0"/>
+              </a:spcAft>
+            </a:pPr>
+            <a:r>
+              <a:rPr sz="900" b="0" i="0">
+                <a:solidFill>
+                  <a:srgbClr val="A8B0C8"/>
+                </a:solidFill>
+                <a:latin typeface="Arial"/>
+              </a:rPr>
+              <a:t>Escanea el QR</a:t>
+            </a:r>
+          </a:p>
+        </p:txBody>
+      </p:sp>
+      <p:sp>
+        <p:nvSpPr>
+          <p:cNvPr id="12" name="TextBox 11"/>
+          <p:cNvSpPr txBox="1"/>
+          <p:nvPr/>
+        </p:nvSpPr>
+        <p:spPr>
+          <a:xfrm>
+            <a:off x="5806440" y="2670048"/>
+            <a:ext cx="2834640" cy="274320"/>
+          </a:xfrm>
+          <a:prstGeom prst="rect">
+            <a:avLst/>
+          </a:prstGeom>
+          <a:noFill/>
+        </p:spPr>
+        <p:txBody>
+          <a:bodyPr wrap="square" lIns="0" rIns="0" tIns="0" bIns="0" anchor="t">
+            <a:spAutoFit/>
+          </a:bodyPr>
+          <a:lstStyle/>
+          <a:p>
+            <a:pPr algn="l">
+              <a:spcBef>
+                <a:spcPts val="0"/>
+              </a:spcBef>
+              <a:spcAft>
+                <a:spcPts val="0"/>
+              </a:spcAft>
+            </a:pPr>
+            <a:r>
+              <a:rPr sz="1100" b="1" i="0">
                 <a:solidFill>
                   <a:srgbClr val="FFFFFF"/>
                 </a:solidFill>
                 <a:latin typeface="Courier New"/>
               </a:rPr>
-              <a:t>&lt;URL-CORTA&gt;</a:t>
-            </a:r>
-          </a:p>
-        </p:txBody>
-      </p:sp>
-      <p:sp>
-        <p:nvSpPr>
-          <p:cNvPr id="12" name="Rectangle 11"/>
+              <a:t>github.com/jossuema/textract-ec</a:t>
+            </a:r>
+          </a:p>
+        </p:txBody>
+      </p:sp>
+      <p:sp>
+        <p:nvSpPr>
+          <p:cNvPr id="13" name="Rectangle 12"/>
           <p:cNvSpPr/>
           <p:nvPr/>
         </p:nvSpPr>
         <p:spPr>
           <a:xfrm>
-            <a:off x="5806440" y="2884932"/>
+            <a:off x="5806440" y="3104388"/>
             <a:ext cx="91440" cy="91440"/>
           </a:xfrm>
           <a:prstGeom prst="rect">
@@ -6900,13 +6923,13 @@
       </p:sp>
       <p:sp>
         <p:nvSpPr>
-          <p:cNvPr id="13" name="TextBox 12"/>
+          <p:cNvPr id="14" name="TextBox 13"/>
           <p:cNvSpPr txBox="1"/>
           <p:nvPr/>
         </p:nvSpPr>
         <p:spPr>
           <a:xfrm>
-            <a:off x="6025896" y="2834640"/>
+            <a:off x="6025896" y="3054096"/>
             <a:ext cx="2615184" cy="329184"/>
           </a:xfrm>
           <a:prstGeom prst="rect">
@@ -6954,13 +6977,13 @@
       </p:sp>
       <p:sp>
         <p:nvSpPr>
-          <p:cNvPr id="14" name="Rectangle 13"/>
+          <p:cNvPr id="15" name="Rectangle 14"/>
           <p:cNvSpPr/>
           <p:nvPr/>
         </p:nvSpPr>
         <p:spPr>
           <a:xfrm>
-            <a:off x="5806440" y="3351276"/>
+            <a:off x="5806440" y="3570732"/>
             <a:ext cx="91440" cy="91440"/>
           </a:xfrm>
           <a:prstGeom prst="rect">
@@ -6998,13 +7021,13 @@
       </p:sp>
       <p:sp>
         <p:nvSpPr>
-          <p:cNvPr id="15" name="TextBox 14"/>
+          <p:cNvPr id="16" name="TextBox 15"/>
           <p:cNvSpPr txBox="1"/>
           <p:nvPr/>
         </p:nvSpPr>
         <p:spPr>
           <a:xfrm>
-            <a:off x="6025896" y="3300984"/>
+            <a:off x="6025896" y="3520439"/>
             <a:ext cx="2615184" cy="329184"/>
           </a:xfrm>
           <a:prstGeom prst="rect">
@@ -7052,13 +7075,13 @@
       </p:sp>
       <p:sp>
         <p:nvSpPr>
-          <p:cNvPr id="16" name="Rectangle 15"/>
+          <p:cNvPr id="17" name="Rectangle 16"/>
           <p:cNvSpPr/>
           <p:nvPr/>
         </p:nvSpPr>
         <p:spPr>
           <a:xfrm>
-            <a:off x="5806440" y="3817620"/>
+            <a:off x="5806440" y="4037075"/>
             <a:ext cx="91440" cy="91440"/>
           </a:xfrm>
           <a:prstGeom prst="rect">
@@ -7096,13 +7119,13 @@
       </p:sp>
       <p:sp>
         <p:nvSpPr>
-          <p:cNvPr id="17" name="TextBox 16"/>
+          <p:cNvPr id="18" name="TextBox 17"/>
           <p:cNvSpPr txBox="1"/>
           <p:nvPr/>
         </p:nvSpPr>
         <p:spPr>
           <a:xfrm>
-            <a:off x="6025896" y="3767328"/>
+            <a:off x="6025896" y="3986783"/>
             <a:ext cx="2615184" cy="182880"/>
           </a:xfrm>
           <a:prstGeom prst="rect">
@@ -17297,7 +17320,7 @@
                 </a:solidFill>
                 <a:latin typeface="Courier New"/>
               </a:rPr>
-              <a:t>&lt;CONTACTO-PONENTE&gt;</a:t>
+              <a:t>github.com/jossuema</a:t>
             </a:r>
           </a:p>
         </p:txBody>
@@ -17355,8 +17378,8 @@
         </p:nvSpPr>
         <p:spPr>
           <a:xfrm>
-            <a:off x="6263640" y="1417320"/>
-            <a:ext cx="1600200" cy="1600200"/>
+            <a:off x="6144768" y="1325880"/>
+            <a:ext cx="1645920" cy="1645920"/>
           </a:xfrm>
           <a:prstGeom prst="rect">
             <a:avLst/>
@@ -17393,68 +17416,30 @@
           </a:p>
         </p:txBody>
       </p:sp>
-      <p:sp>
-        <p:nvSpPr>
-          <p:cNvPr id="10" name="TextBox 9"/>
-          <p:cNvSpPr txBox="1"/>
-          <p:nvPr/>
-        </p:nvSpPr>
-        <p:spPr>
-          <a:xfrm>
-            <a:off x="6309360" y="2011680"/>
-            <a:ext cx="1508760" cy="502920"/>
-          </a:xfrm>
-          <a:prstGeom prst="rect">
-            <a:avLst/>
-          </a:prstGeom>
-          <a:noFill/>
-        </p:spPr>
-        <p:txBody>
-          <a:bodyPr wrap="square" lIns="0" rIns="0" tIns="0" bIns="0" anchor="ctr">
-            <a:spAutoFit/>
-          </a:bodyPr>
-          <a:lstStyle/>
-          <a:p>
-            <a:pPr algn="ctr">
-              <a:spcBef>
-                <a:spcPts val="0"/>
-              </a:spcBef>
-              <a:spcAft>
-                <a:spcPts val="0"/>
-              </a:spcAft>
-            </a:pPr>
-            <a:r>
-              <a:rPr sz="1400" b="1" i="0">
-                <a:solidFill>
-                  <a:srgbClr val="0B1338"/>
-                </a:solidFill>
-                <a:latin typeface="Arial"/>
-              </a:rPr>
-              <a:t>QR</a:t>
-            </a:r>
-          </a:p>
-          <a:p>
-            <a:pPr algn="ctr">
-              <a:spcBef>
-                <a:spcPts val="0"/>
-              </a:spcBef>
-              <a:spcAft>
-                <a:spcPts val="0"/>
-              </a:spcAft>
-            </a:pPr>
-            <a:r>
-              <a:rPr sz="750" b="0" i="0">
-                <a:solidFill>
-                  <a:srgbClr val="5A6076"/>
-                </a:solidFill>
-                <a:latin typeface="Arial"/>
-              </a:rPr>
-              <a:t>github.com/&lt;usuario&gt;/
-textract-ec</a:t>
-            </a:r>
-          </a:p>
-        </p:txBody>
-      </p:sp>
+      <p:pic>
+        <p:nvPicPr>
+          <p:cNvPr id="10" name="Picture 9" descr="qr-repo.png"/>
+          <p:cNvPicPr>
+            <a:picLocks noChangeAspect="1"/>
+          </p:cNvPicPr>
+          <p:nvPr/>
+        </p:nvPicPr>
+        <p:blipFill>
+          <a:blip r:embed="rId5"/>
+          <a:stretch>
+            <a:fillRect/>
+          </a:stretch>
+        </p:blipFill>
+        <p:spPr>
+          <a:xfrm>
+            <a:off x="6217920" y="1399032"/>
+            <a:ext cx="1499616" cy="1499616"/>
+          </a:xfrm>
+          <a:prstGeom prst="rect">
+            <a:avLst/>
+          </a:prstGeom>
+        </p:spPr>
+      </p:pic>
       <p:sp>
         <p:nvSpPr>
           <p:cNvPr id="11" name="TextBox 10"/>
@@ -17463,8 +17448,8 @@
         </p:nvSpPr>
         <p:spPr>
           <a:xfrm>
-            <a:off x="6263640" y="3154680"/>
-            <a:ext cx="1600200" cy="365760"/>
+            <a:off x="5577840" y="3090672"/>
+            <a:ext cx="3063240" cy="292608"/>
           </a:xfrm>
           <a:prstGeom prst="rect">
             <a:avLst/>
@@ -17486,13 +17471,13 @@
               </a:spcAft>
             </a:pPr>
             <a:r>
-              <a:rPr sz="1300" b="1" i="0">
+              <a:rPr sz="1150" b="1" i="0">
                 <a:solidFill>
                   <a:srgbClr val="FFFFFF"/>
                 </a:solidFill>
                 <a:latin typeface="Courier New"/>
               </a:rPr>
-              <a:t>&lt;URL-CORTA&gt;</a:t>
+              <a:t>github.com/jossuema/textract-ec</a:t>
             </a:r>
           </a:p>
         </p:txBody>
@@ -20381,13 +20366,22 @@
               </a:spcAft>
             </a:pPr>
             <a:r>
-              <a:rPr sz="1000">
+              <a:rPr sz="950">
                 <a:solidFill>
                   <a:srgbClr val="E8EAF0"/>
                 </a:solidFill>
                 <a:latin typeface="Courier New"/>
               </a:rPr>
-              <a:t>git clone --depth 1 &lt;URL-REPO&gt; &amp;&amp; cd textract-ec</a:t>
+              <a:t>git clone --depth 1 https:</a:t>
+            </a:r>
+            <a:r>
+              <a:rPr sz="950">
+                <a:solidFill>
+                  <a:srgbClr val="A8B0C8"/>
+                </a:solidFill>
+                <a:latin typeface="Courier New"/>
+              </a:rPr>
+              <a:t>//github.com/jossuema/textract-ec</a:t>
             </a:r>
           </a:p>
           <a:p>
@@ -20400,13 +20394,13 @@
               </a:spcAft>
             </a:pPr>
             <a:r>
-              <a:rPr sz="1000">
+              <a:rPr sz="950">
                 <a:solidFill>
                   <a:srgbClr val="E8EAF0"/>
                 </a:solidFill>
                 <a:latin typeface="Courier New"/>
               </a:rPr>
-              <a:t>python3 00_check.py</a:t>
+              <a:t>cd textract-ec &amp;&amp; python3 00_check.py</a:t>
             </a:r>
           </a:p>
           <a:p>
@@ -20419,7 +20413,7 @@
               </a:spcAft>
             </a:pPr>
             <a:r>
-              <a:rPr sz="1000">
+              <a:rPr sz="950">
                 <a:solidFill>
                   <a:srgbClr val="E8EAF0"/>
                 </a:solidFill>
@@ -20428,7 +20422,7 @@
               <a:t>python3 -m pip install --user pillow   </a:t>
             </a:r>
             <a:r>
-              <a:rPr sz="1000">
+              <a:rPr sz="950">
                 <a:solidFill>
                   <a:srgbClr val="A8B0C8"/>
                 </a:solidFill>

</xml_diff>